<commit_message>
Retirer les tirets cadratins et vider la couverture du livre héros
- Remplacement de tous les tirets cadratins « — » du texte visible par une
  ponctuation plus naturelle (virgule, deux-points ou « · » selon le contexte)
  et nettoyage des commentaires de code, du dump SQL et des schémas.
- Régénération des fichiers de démonstration (PDF et deux présentations
  PowerPoint) sans tiret cadratin.
- Couverture du livre mis en avant sur l'accueil laissée vide (sans titre
  imprimé), rendu ornemental seul.
- « Lectrices » → « Lecteurs » sur le badge du héros (cohérence).

Co-Authored-By: Claude Opus 4.8 <noreply@anthropic.com>
Claude-Session: https://claude.ai/code/session_01EE8SbdEhXJYx5xZskZsGix
</commit_message>
<xml_diff>
--- a/uploads/pdf/presentation-exemple.pptx
+++ b/uploads/pdf/presentation-exemple.pptx
@@ -508,7 +508,7 @@
           <a:lstStyle/>
           <a:p>
             <a:r>
-              <a:t>Rappeler que la présentation se lit directement dans le navigateur, sans PowerPoint installé.</a:t>
+              <a:t>La présentation se lit directement dans le navigateur, sans PowerPoint installé.</a:t>
             </a:r>
           </a:p>
         </p:txBody>
@@ -3621,7 +3621,7 @@
           <a:lstStyle/>
           <a:p>
             <a:r>
-              <a:t>La Bibliothèque Numérique — présentation de démonstration</a:t>
+              <a:t>La Bibliothèque Numérique · présentation de démonstration</a:t>
             </a:r>
           </a:p>
         </p:txBody>

</xml_diff>